<commit_message>
regional correlations with lags; remove covid; cluster add plots WIP; plots
</commit_message>
<xml_diff>
--- a/Анализ.pptx
+++ b/Анализ.pptx
@@ -5,20 +5,26 @@
     <p:sldMasterId id="2147483648" r:id="rId1"/>
   </p:sldMasterIdLst>
   <p:sldIdLst>
-    <p:sldId id="256" r:id="rId2"/>
-    <p:sldId id="259" r:id="rId3"/>
-    <p:sldId id="263" r:id="rId4"/>
-    <p:sldId id="257" r:id="rId5"/>
-    <p:sldId id="261" r:id="rId6"/>
-    <p:sldId id="262" r:id="rId7"/>
-    <p:sldId id="264" r:id="rId8"/>
-    <p:sldId id="267" r:id="rId9"/>
-    <p:sldId id="265" r:id="rId10"/>
-    <p:sldId id="268" r:id="rId11"/>
-    <p:sldId id="266" r:id="rId12"/>
-    <p:sldId id="258" r:id="rId13"/>
-    <p:sldId id="269" r:id="rId14"/>
-    <p:sldId id="260" r:id="rId15"/>
+    <p:sldId id="256" r:id="rId3"/>
+    <p:sldId id="259" r:id="rId4"/>
+    <p:sldId id="263" r:id="rId5"/>
+    <p:sldId id="257" r:id="rId6"/>
+    <p:sldId id="261" r:id="rId7"/>
+    <p:sldId id="262" r:id="rId8"/>
+    <p:sldId id="264" r:id="rId9"/>
+    <p:sldId id="267" r:id="rId10"/>
+    <p:sldId id="265" r:id="rId11"/>
+    <p:sldId id="268" r:id="rId12"/>
+    <p:sldId id="266" r:id="rId13"/>
+    <p:sldId id="258" r:id="rId14"/>
+    <p:sldId id="272" r:id="rId15"/>
+    <p:sldId id="270" r:id="rId16"/>
+    <p:sldId id="271" r:id="rId17"/>
+    <p:sldId id="273" r:id="rId18"/>
+    <p:sldId id="274" r:id="rId19"/>
+    <p:sldId id="275" r:id="rId20"/>
+    <p:sldId id="269" r:id="rId21"/>
+    <p:sldId id="260" r:id="rId22"/>
   </p:sldIdLst>
   <p:sldSz cx="12192000" cy="6858000"/>
   <p:notesSz cx="6858000" cy="9144000"/>
@@ -121,7 +127,7 @@
 </file>
 
 <file path=ppt/slideLayouts/slideLayout1.xml><?xml version="1.0" encoding="utf-8"?>
-<p:sldLayout xmlns:a="http://schemas.openxmlformats.org/drawingml/2006/main" xmlns:r="http://schemas.openxmlformats.org/officeDocument/2006/relationships" xmlns:p="http://schemas.openxmlformats.org/presentationml/2006/main" showMasterSp="0" type="title" preserve="1">
+<p:sldLayout xmlns:a="http://schemas.openxmlformats.org/drawingml/2006/main" xmlns:r="http://schemas.openxmlformats.org/officeDocument/2006/relationships" xmlns:p="http://schemas.openxmlformats.org/presentationml/2006/main" type="title" preserve="1" showMasterSp="0">
   <p:cSld name="Title Slide">
     <p:spTree>
       <p:nvGrpSpPr>
@@ -272,7 +278,6 @@
           <a:p>
             <a:fld id="{6AD6EE87-EBD5-4F12-A48A-63ACA297AC8F}" type="datetimeFigureOut">
               <a:rPr lang="en-US" dirty="0"/>
-              <a:t>6/11/2026</a:t>
             </a:fld>
             <a:endParaRPr lang="en-US" dirty="0"/>
           </a:p>
@@ -314,7 +319,6 @@
           <a:p>
             <a:fld id="{4FAB73BC-B049-4115-A692-8D63A059BFB8}" type="slidenum">
               <a:rPr lang="en-US" dirty="0"/>
-              <a:t>‹#›</a:t>
             </a:fld>
             <a:endParaRPr lang="en-US" dirty="0"/>
           </a:p>
@@ -461,6 +465,7 @@
               <a:rPr lang="en-US" smtClean="0"/>
               <a:t>Edit Master text styles</a:t>
             </a:r>
+            <a:endParaRPr lang="en-US" smtClean="0"/>
           </a:p>
           <a:p>
             <a:pPr lvl="1"/>
@@ -468,6 +473,7 @@
               <a:rPr lang="en-US" smtClean="0"/>
               <a:t>Second level</a:t>
             </a:r>
+            <a:endParaRPr lang="en-US" smtClean="0"/>
           </a:p>
           <a:p>
             <a:pPr lvl="2"/>
@@ -475,6 +481,7 @@
               <a:rPr lang="en-US" smtClean="0"/>
               <a:t>Third level</a:t>
             </a:r>
+            <a:endParaRPr lang="en-US" smtClean="0"/>
           </a:p>
           <a:p>
             <a:pPr lvl="3"/>
@@ -482,6 +489,7 @@
               <a:rPr lang="en-US" smtClean="0"/>
               <a:t>Fourth level</a:t>
             </a:r>
+            <a:endParaRPr lang="en-US" smtClean="0"/>
           </a:p>
           <a:p>
             <a:pPr lvl="4"/>
@@ -510,7 +518,6 @@
           <a:p>
             <a:fld id="{4CD73815-2707-4475-8F1A-B873CB631BB4}" type="datetimeFigureOut">
               <a:rPr lang="en-US" dirty="0"/>
-              <a:t>6/11/2026</a:t>
             </a:fld>
             <a:endParaRPr lang="en-US" dirty="0"/>
           </a:p>
@@ -552,7 +559,6 @@
           <a:p>
             <a:fld id="{4FAB73BC-B049-4115-A692-8D63A059BFB8}" type="slidenum">
               <a:rPr lang="en-US" dirty="0"/>
-              <a:t>‹#›</a:t>
             </a:fld>
             <a:endParaRPr lang="en-US" dirty="0"/>
           </a:p>
@@ -567,7 +573,7 @@
 </file>
 
 <file path=ppt/slideLayouts/slideLayout11.xml><?xml version="1.0" encoding="utf-8"?>
-<p:sldLayout xmlns:a="http://schemas.openxmlformats.org/drawingml/2006/main" xmlns:r="http://schemas.openxmlformats.org/officeDocument/2006/relationships" xmlns:p="http://schemas.openxmlformats.org/presentationml/2006/main" showMasterSp="0" type="vertTitleAndTx" preserve="1">
+<p:sldLayout xmlns:a="http://schemas.openxmlformats.org/drawingml/2006/main" xmlns:r="http://schemas.openxmlformats.org/officeDocument/2006/relationships" xmlns:p="http://schemas.openxmlformats.org/presentationml/2006/main" type="vertTitleAndTx" preserve="1" showMasterSp="0">
   <p:cSld name="Vertical Title and Text">
     <p:spTree>
       <p:nvGrpSpPr>
@@ -636,6 +642,7 @@
               <a:rPr lang="en-US" smtClean="0"/>
               <a:t>Edit Master text styles</a:t>
             </a:r>
+            <a:endParaRPr lang="en-US" smtClean="0"/>
           </a:p>
           <a:p>
             <a:pPr lvl="1"/>
@@ -643,6 +650,7 @@
               <a:rPr lang="en-US" smtClean="0"/>
               <a:t>Second level</a:t>
             </a:r>
+            <a:endParaRPr lang="en-US" smtClean="0"/>
           </a:p>
           <a:p>
             <a:pPr lvl="2"/>
@@ -650,6 +658,7 @@
               <a:rPr lang="en-US" smtClean="0"/>
               <a:t>Third level</a:t>
             </a:r>
+            <a:endParaRPr lang="en-US" smtClean="0"/>
           </a:p>
           <a:p>
             <a:pPr lvl="3"/>
@@ -657,6 +666,7 @@
               <a:rPr lang="en-US" smtClean="0"/>
               <a:t>Fourth level</a:t>
             </a:r>
+            <a:endParaRPr lang="en-US" smtClean="0"/>
           </a:p>
           <a:p>
             <a:pPr lvl="4"/>
@@ -685,7 +695,6 @@
           <a:p>
             <a:fld id="{2A4AFB99-0EAB-4182-AFF8-E214C82A68F6}" type="datetimeFigureOut">
               <a:rPr lang="en-US" dirty="0"/>
-              <a:t>6/11/2026</a:t>
             </a:fld>
             <a:endParaRPr lang="en-US" dirty="0"/>
           </a:p>
@@ -727,7 +736,6 @@
           <a:p>
             <a:fld id="{4FAB73BC-B049-4115-A692-8D63A059BFB8}" type="slidenum">
               <a:rPr lang="en-US" dirty="0"/>
-              <a:t>‹#›</a:t>
             </a:fld>
             <a:endParaRPr lang="en-US" dirty="0"/>
           </a:p>
@@ -776,6 +784,173 @@
 </p:sldLayout>
 </file>
 
+<file path=ppt/slideLayouts/slideLayout12.xml><?xml version="1.0" encoding="utf-8"?>
+<p:sldLayout xmlns:a="http://schemas.openxmlformats.org/drawingml/2006/main" xmlns:r="http://schemas.openxmlformats.org/officeDocument/2006/relationships" xmlns:p="http://schemas.openxmlformats.org/presentationml/2006/main" type="tx" preserve="1">
+  <p:cSld name="Title and Text">
+    <p:spTree>
+      <p:nvGrpSpPr>
+        <p:cNvPr id="1" name=""/>
+        <p:cNvGrpSpPr/>
+        <p:nvPr/>
+      </p:nvGrpSpPr>
+      <p:grpSpPr>
+        <a:xfrm>
+          <a:off x="0" y="0"/>
+          <a:ext cx="0" cy="0"/>
+          <a:chOff x="0" y="0"/>
+          <a:chExt cx="0" cy="0"/>
+        </a:xfrm>
+      </p:grpSpPr>
+      <p:sp>
+        <p:nvSpPr>
+          <p:cNvPr id="2" name="Title 1"/>
+          <p:cNvSpPr>
+            <a:spLocks noGrp="1"/>
+          </p:cNvSpPr>
+          <p:nvPr>
+            <p:ph type="title"/>
+          </p:nvPr>
+        </p:nvSpPr>
+        <p:spPr/>
+        <p:txBody>
+          <a:bodyPr/>
+          <a:lstStyle/>
+          <a:p>
+            <a:r>
+              <a:rPr lang="en-US" smtClean="0"/>
+              <a:t>Click to edit Master title style</a:t>
+            </a:r>
+            <a:endParaRPr lang="en-US"/>
+          </a:p>
+        </p:txBody>
+      </p:sp>
+      <p:sp>
+        <p:nvSpPr>
+          <p:cNvPr id="3" name="Text Placeholder 2"/>
+          <p:cNvSpPr>
+            <a:spLocks noGrp="1"/>
+          </p:cNvSpPr>
+          <p:nvPr>
+            <p:ph type="body" idx="1"/>
+          </p:nvPr>
+        </p:nvSpPr>
+        <p:spPr/>
+        <p:txBody>
+          <a:bodyPr/>
+          <a:lstStyle/>
+          <a:p>
+            <a:pPr lvl="0"/>
+            <a:r>
+              <a:rPr lang="en-US" smtClean="0"/>
+              <a:t>Click to edit Master text styles</a:t>
+            </a:r>
+            <a:endParaRPr lang="en-US" smtClean="0"/>
+          </a:p>
+          <a:p>
+            <a:pPr lvl="1"/>
+            <a:r>
+              <a:rPr lang="en-US" smtClean="0"/>
+              <a:t>Second level</a:t>
+            </a:r>
+            <a:endParaRPr lang="en-US" smtClean="0"/>
+          </a:p>
+          <a:p>
+            <a:pPr lvl="2"/>
+            <a:r>
+              <a:rPr lang="en-US" smtClean="0"/>
+              <a:t>Third level</a:t>
+            </a:r>
+            <a:endParaRPr lang="en-US" smtClean="0"/>
+          </a:p>
+          <a:p>
+            <a:pPr lvl="3"/>
+            <a:r>
+              <a:rPr lang="en-US" smtClean="0"/>
+              <a:t>Fourth level</a:t>
+            </a:r>
+            <a:endParaRPr lang="en-US" smtClean="0"/>
+          </a:p>
+          <a:p>
+            <a:pPr lvl="4"/>
+            <a:r>
+              <a:rPr lang="en-US" smtClean="0"/>
+              <a:t>Fifth level</a:t>
+            </a:r>
+            <a:endParaRPr lang="en-US"/>
+          </a:p>
+        </p:txBody>
+      </p:sp>
+      <p:sp>
+        <p:nvSpPr>
+          <p:cNvPr id="4" name="Date Placeholder 3"/>
+          <p:cNvSpPr>
+            <a:spLocks noGrp="1"/>
+          </p:cNvSpPr>
+          <p:nvPr>
+            <p:ph type="dt" sz="half" idx="10"/>
+          </p:nvPr>
+        </p:nvSpPr>
+        <p:spPr/>
+        <p:txBody>
+          <a:bodyPr/>
+          <a:lstStyle/>
+          <a:p>
+            <a:fld id="{90298CD5-6C1E-4009-B41F-6DF62E31D3BE}" type="datetimeFigureOut">
+              <a:rPr lang="en-US" dirty="0"/>
+            </a:fld>
+            <a:endParaRPr lang="en-US" dirty="0"/>
+          </a:p>
+        </p:txBody>
+      </p:sp>
+      <p:sp>
+        <p:nvSpPr>
+          <p:cNvPr id="5" name="Footer Placeholder 4"/>
+          <p:cNvSpPr>
+            <a:spLocks noGrp="1"/>
+          </p:cNvSpPr>
+          <p:nvPr>
+            <p:ph type="ftr" sz="quarter" idx="11"/>
+          </p:nvPr>
+        </p:nvSpPr>
+        <p:spPr/>
+        <p:txBody>
+          <a:bodyPr/>
+          <a:lstStyle/>
+          <a:p>
+            <a:endParaRPr lang="en-US" dirty="0"/>
+          </a:p>
+        </p:txBody>
+      </p:sp>
+      <p:sp>
+        <p:nvSpPr>
+          <p:cNvPr id="6" name="Slide Number Placeholder 5"/>
+          <p:cNvSpPr>
+            <a:spLocks noGrp="1"/>
+          </p:cNvSpPr>
+          <p:nvPr>
+            <p:ph type="sldNum" sz="quarter" idx="12"/>
+          </p:nvPr>
+        </p:nvSpPr>
+        <p:spPr/>
+        <p:txBody>
+          <a:bodyPr/>
+          <a:lstStyle/>
+          <a:p>
+            <a:fld id="{4FAB73BC-B049-4115-A692-8D63A059BFB8}" type="slidenum">
+              <a:rPr lang="en-US" dirty="0"/>
+            </a:fld>
+            <a:endParaRPr lang="en-US" dirty="0"/>
+          </a:p>
+        </p:txBody>
+      </p:sp>
+    </p:spTree>
+  </p:cSld>
+  <p:clrMapOvr>
+    <a:masterClrMapping/>
+  </p:clrMapOvr>
+</p:sldLayout>
+</file>
+
 <file path=ppt/slideLayouts/slideLayout2.xml><?xml version="1.0" encoding="utf-8"?>
 <p:sldLayout xmlns:a="http://schemas.openxmlformats.org/drawingml/2006/main" xmlns:r="http://schemas.openxmlformats.org/officeDocument/2006/relationships" xmlns:p="http://schemas.openxmlformats.org/presentationml/2006/main" type="obj" preserve="1">
   <p:cSld name="Title and Content">
@@ -836,6 +1011,7 @@
               <a:rPr lang="en-US" smtClean="0"/>
               <a:t>Edit Master text styles</a:t>
             </a:r>
+            <a:endParaRPr lang="en-US" smtClean="0"/>
           </a:p>
           <a:p>
             <a:pPr lvl="1"/>
@@ -843,6 +1019,7 @@
               <a:rPr lang="en-US" smtClean="0"/>
               <a:t>Second level</a:t>
             </a:r>
+            <a:endParaRPr lang="en-US" smtClean="0"/>
           </a:p>
           <a:p>
             <a:pPr lvl="2"/>
@@ -850,6 +1027,7 @@
               <a:rPr lang="en-US" smtClean="0"/>
               <a:t>Third level</a:t>
             </a:r>
+            <a:endParaRPr lang="en-US" smtClean="0"/>
           </a:p>
           <a:p>
             <a:pPr lvl="3"/>
@@ -857,6 +1035,7 @@
               <a:rPr lang="en-US" smtClean="0"/>
               <a:t>Fourth level</a:t>
             </a:r>
+            <a:endParaRPr lang="en-US" smtClean="0"/>
           </a:p>
           <a:p>
             <a:pPr lvl="4"/>
@@ -885,7 +1064,6 @@
           <a:p>
             <a:fld id="{A5D3794B-289A-4A80-97D7-111025398D45}" type="datetimeFigureOut">
               <a:rPr lang="en-US" dirty="0"/>
-              <a:t>6/11/2026</a:t>
             </a:fld>
             <a:endParaRPr lang="en-US" dirty="0"/>
           </a:p>
@@ -927,7 +1105,6 @@
           <a:p>
             <a:fld id="{4FAB73BC-B049-4115-A692-8D63A059BFB8}" type="slidenum">
               <a:rPr lang="en-US" dirty="0"/>
-              <a:t>‹#›</a:t>
             </a:fld>
             <a:endParaRPr lang="en-US" dirty="0"/>
           </a:p>
@@ -942,7 +1119,7 @@
 </file>
 
 <file path=ppt/slideLayouts/slideLayout3.xml><?xml version="1.0" encoding="utf-8"?>
-<p:sldLayout xmlns:a="http://schemas.openxmlformats.org/drawingml/2006/main" xmlns:r="http://schemas.openxmlformats.org/officeDocument/2006/relationships" xmlns:p="http://schemas.openxmlformats.org/presentationml/2006/main" showMasterSp="0" type="secHead" preserve="1">
+<p:sldLayout xmlns:a="http://schemas.openxmlformats.org/drawingml/2006/main" xmlns:r="http://schemas.openxmlformats.org/officeDocument/2006/relationships" xmlns:p="http://schemas.openxmlformats.org/presentationml/2006/main" type="secHead" preserve="1" showMasterSp="0">
   <p:cSld name="Section Header">
     <p:spTree>
       <p:nvGrpSpPr>
@@ -1117,6 +1294,7 @@
               <a:rPr lang="en-US" smtClean="0"/>
               <a:t>Edit Master text styles</a:t>
             </a:r>
+            <a:endParaRPr lang="en-US" smtClean="0"/>
           </a:p>
         </p:txBody>
       </p:sp>
@@ -1137,7 +1315,6 @@
           <a:p>
             <a:fld id="{5A61015F-7CC6-4D0A-9D87-873EA4C304CC}" type="datetimeFigureOut">
               <a:rPr lang="en-US" dirty="0"/>
-              <a:t>6/11/2026</a:t>
             </a:fld>
             <a:endParaRPr lang="en-US" dirty="0"/>
           </a:p>
@@ -1179,7 +1356,6 @@
           <a:p>
             <a:fld id="{4FAB73BC-B049-4115-A692-8D63A059BFB8}" type="slidenum">
               <a:rPr lang="en-US" dirty="0"/>
-              <a:t>‹#›</a:t>
             </a:fld>
             <a:endParaRPr lang="en-US" dirty="0"/>
           </a:p>
@@ -1373,6 +1549,7 @@
               <a:rPr lang="en-US" smtClean="0"/>
               <a:t>Edit Master text styles</a:t>
             </a:r>
+            <a:endParaRPr lang="en-US" smtClean="0"/>
           </a:p>
           <a:p>
             <a:pPr lvl="1"/>
@@ -1380,6 +1557,7 @@
               <a:rPr lang="en-US" smtClean="0"/>
               <a:t>Second level</a:t>
             </a:r>
+            <a:endParaRPr lang="en-US" smtClean="0"/>
           </a:p>
           <a:p>
             <a:pPr lvl="2"/>
@@ -1387,6 +1565,7 @@
               <a:rPr lang="en-US" smtClean="0"/>
               <a:t>Third level</a:t>
             </a:r>
+            <a:endParaRPr lang="en-US" smtClean="0"/>
           </a:p>
           <a:p>
             <a:pPr lvl="3"/>
@@ -1394,6 +1573,7 @@
               <a:rPr lang="en-US" smtClean="0"/>
               <a:t>Fourth level</a:t>
             </a:r>
+            <a:endParaRPr lang="en-US" smtClean="0"/>
           </a:p>
           <a:p>
             <a:pPr lvl="4"/>
@@ -1430,6 +1610,7 @@
               <a:rPr lang="en-US" smtClean="0"/>
               <a:t>Edit Master text styles</a:t>
             </a:r>
+            <a:endParaRPr lang="en-US" smtClean="0"/>
           </a:p>
           <a:p>
             <a:pPr lvl="1"/>
@@ -1437,6 +1618,7 @@
               <a:rPr lang="en-US" smtClean="0"/>
               <a:t>Second level</a:t>
             </a:r>
+            <a:endParaRPr lang="en-US" smtClean="0"/>
           </a:p>
           <a:p>
             <a:pPr lvl="2"/>
@@ -1444,6 +1626,7 @@
               <a:rPr lang="en-US" smtClean="0"/>
               <a:t>Third level</a:t>
             </a:r>
+            <a:endParaRPr lang="en-US" smtClean="0"/>
           </a:p>
           <a:p>
             <a:pPr lvl="3"/>
@@ -1451,6 +1634,7 @@
               <a:rPr lang="en-US" smtClean="0"/>
               <a:t>Fourth level</a:t>
             </a:r>
+            <a:endParaRPr lang="en-US" smtClean="0"/>
           </a:p>
           <a:p>
             <a:pPr lvl="4"/>
@@ -1479,7 +1663,6 @@
           <a:p>
             <a:fld id="{93C6A301-0538-44EC-B09D-202E1042A48B}" type="datetimeFigureOut">
               <a:rPr lang="en-US" dirty="0"/>
-              <a:t>6/11/2026</a:t>
             </a:fld>
             <a:endParaRPr lang="en-US" dirty="0"/>
           </a:p>
@@ -1521,7 +1704,6 @@
           <a:p>
             <a:fld id="{4FAB73BC-B049-4115-A692-8D63A059BFB8}" type="slidenum">
               <a:rPr lang="en-US" dirty="0"/>
-              <a:t>‹#›</a:t>
             </a:fld>
             <a:endParaRPr lang="en-US" dirty="0"/>
           </a:p>
@@ -1652,6 +1834,7 @@
               <a:rPr lang="en-US" smtClean="0"/>
               <a:t>Edit Master text styles</a:t>
             </a:r>
+            <a:endParaRPr lang="en-US" smtClean="0"/>
           </a:p>
         </p:txBody>
       </p:sp>
@@ -1680,6 +1863,7 @@
               <a:rPr lang="en-US" smtClean="0"/>
               <a:t>Edit Master text styles</a:t>
             </a:r>
+            <a:endParaRPr lang="en-US" smtClean="0"/>
           </a:p>
           <a:p>
             <a:pPr lvl="1"/>
@@ -1687,6 +1871,7 @@
               <a:rPr lang="en-US" smtClean="0"/>
               <a:t>Second level</a:t>
             </a:r>
+            <a:endParaRPr lang="en-US" smtClean="0"/>
           </a:p>
           <a:p>
             <a:pPr lvl="2"/>
@@ -1694,6 +1879,7 @@
               <a:rPr lang="en-US" smtClean="0"/>
               <a:t>Third level</a:t>
             </a:r>
+            <a:endParaRPr lang="en-US" smtClean="0"/>
           </a:p>
           <a:p>
             <a:pPr lvl="3"/>
@@ -1701,6 +1887,7 @@
               <a:rPr lang="en-US" smtClean="0"/>
               <a:t>Fourth level</a:t>
             </a:r>
+            <a:endParaRPr lang="en-US" smtClean="0"/>
           </a:p>
           <a:p>
             <a:pPr lvl="4"/>
@@ -1799,6 +1986,7 @@
               <a:rPr lang="en-US" smtClean="0"/>
               <a:t>Edit Master text styles</a:t>
             </a:r>
+            <a:endParaRPr lang="en-US" smtClean="0"/>
           </a:p>
         </p:txBody>
       </p:sp>
@@ -1827,6 +2015,7 @@
               <a:rPr lang="en-US" smtClean="0"/>
               <a:t>Edit Master text styles</a:t>
             </a:r>
+            <a:endParaRPr lang="en-US" smtClean="0"/>
           </a:p>
           <a:p>
             <a:pPr lvl="1"/>
@@ -1834,6 +2023,7 @@
               <a:rPr lang="en-US" smtClean="0"/>
               <a:t>Second level</a:t>
             </a:r>
+            <a:endParaRPr lang="en-US" smtClean="0"/>
           </a:p>
           <a:p>
             <a:pPr lvl="2"/>
@@ -1841,6 +2031,7 @@
               <a:rPr lang="en-US" smtClean="0"/>
               <a:t>Third level</a:t>
             </a:r>
+            <a:endParaRPr lang="en-US" smtClean="0"/>
           </a:p>
           <a:p>
             <a:pPr lvl="3"/>
@@ -1848,6 +2039,7 @@
               <a:rPr lang="en-US" smtClean="0"/>
               <a:t>Fourth level</a:t>
             </a:r>
+            <a:endParaRPr lang="en-US" smtClean="0"/>
           </a:p>
           <a:p>
             <a:pPr lvl="4"/>
@@ -1876,7 +2068,6 @@
           <a:p>
             <a:fld id="{D789574A-8875-45EF-8EA2-3CAA0F7ABC4C}" type="datetimeFigureOut">
               <a:rPr lang="en-US" dirty="0"/>
-              <a:t>6/11/2026</a:t>
             </a:fld>
             <a:endParaRPr lang="en-US" dirty="0"/>
           </a:p>
@@ -1918,7 +2109,6 @@
           <a:p>
             <a:fld id="{4FAB73BC-B049-4115-A692-8D63A059BFB8}" type="slidenum">
               <a:rPr lang="en-US" dirty="0"/>
-              <a:t>‹#›</a:t>
             </a:fld>
             <a:endParaRPr lang="en-US" dirty="0"/>
           </a:p>
@@ -1989,7 +2179,6 @@
           <a:p>
             <a:fld id="{67EF4D4C-5367-4C26-9E2B-D8088D7FCA81}" type="datetimeFigureOut">
               <a:rPr lang="en-US" dirty="0"/>
-              <a:t>6/11/2026</a:t>
             </a:fld>
             <a:endParaRPr lang="en-US" dirty="0"/>
           </a:p>
@@ -2031,7 +2220,6 @@
           <a:p>
             <a:fld id="{4FAB73BC-B049-4115-A692-8D63A059BFB8}" type="slidenum">
               <a:rPr lang="en-US" dirty="0"/>
-              <a:t>‹#›</a:t>
             </a:fld>
             <a:endParaRPr lang="en-US" dirty="0"/>
           </a:p>
@@ -2046,7 +2234,7 @@
 </file>
 
 <file path=ppt/slideLayouts/slideLayout7.xml><?xml version="1.0" encoding="utf-8"?>
-<p:sldLayout xmlns:a="http://schemas.openxmlformats.org/drawingml/2006/main" xmlns:r="http://schemas.openxmlformats.org/officeDocument/2006/relationships" xmlns:p="http://schemas.openxmlformats.org/presentationml/2006/main" showMasterSp="0" type="blank" preserve="1">
+<p:sldLayout xmlns:a="http://schemas.openxmlformats.org/drawingml/2006/main" xmlns:r="http://schemas.openxmlformats.org/officeDocument/2006/relationships" xmlns:p="http://schemas.openxmlformats.org/presentationml/2006/main" type="blank" preserve="1" showMasterSp="0">
   <p:cSld name="Blank">
     <p:spTree>
       <p:nvGrpSpPr>
@@ -2079,7 +2267,6 @@
           <a:p>
             <a:fld id="{56E91E96-98B0-4413-9547-46F3504108EF}" type="datetimeFigureOut">
               <a:rPr lang="en-US" dirty="0"/>
-              <a:t>6/11/2026</a:t>
             </a:fld>
             <a:endParaRPr lang="en-US" dirty="0"/>
           </a:p>
@@ -2121,7 +2308,6 @@
           <a:p>
             <a:fld id="{4FAB73BC-B049-4115-A692-8D63A059BFB8}" type="slidenum">
               <a:rPr lang="en-US" dirty="0"/>
-              <a:t>‹#›</a:t>
             </a:fld>
             <a:endParaRPr lang="en-US" dirty="0"/>
           </a:p>
@@ -2242,6 +2428,7 @@
               <a:rPr lang="en-US" smtClean="0"/>
               <a:t>Edit Master text styles</a:t>
             </a:r>
+            <a:endParaRPr lang="en-US" smtClean="0"/>
           </a:p>
           <a:p>
             <a:pPr lvl="1"/>
@@ -2249,6 +2436,7 @@
               <a:rPr lang="en-US" smtClean="0"/>
               <a:t>Second level</a:t>
             </a:r>
+            <a:endParaRPr lang="en-US" smtClean="0"/>
           </a:p>
           <a:p>
             <a:pPr lvl="2"/>
@@ -2256,6 +2444,7 @@
               <a:rPr lang="en-US" smtClean="0"/>
               <a:t>Third level</a:t>
             </a:r>
+            <a:endParaRPr lang="en-US" smtClean="0"/>
           </a:p>
           <a:p>
             <a:pPr lvl="3"/>
@@ -2263,6 +2452,7 @@
               <a:rPr lang="en-US" smtClean="0"/>
               <a:t>Fourth level</a:t>
             </a:r>
+            <a:endParaRPr lang="en-US" smtClean="0"/>
           </a:p>
           <a:p>
             <a:pPr lvl="4"/>
@@ -2344,6 +2534,7 @@
               <a:rPr lang="en-US" smtClean="0"/>
               <a:t>Edit Master text styles</a:t>
             </a:r>
+            <a:endParaRPr lang="en-US" smtClean="0"/>
           </a:p>
         </p:txBody>
       </p:sp>
@@ -2364,7 +2555,6 @@
           <a:p>
             <a:fld id="{05C68B11-C5A8-448C-8CE9-B1A273C79CFC}" type="datetimeFigureOut">
               <a:rPr lang="en-US" dirty="0"/>
-              <a:t>6/11/2026</a:t>
             </a:fld>
             <a:endParaRPr lang="en-US" dirty="0"/>
           </a:p>
@@ -2406,7 +2596,6 @@
           <a:p>
             <a:fld id="{4FAB73BC-B049-4115-A692-8D63A059BFB8}" type="slidenum">
               <a:rPr lang="en-US" dirty="0"/>
-              <a:t>‹#›</a:t>
             </a:fld>
             <a:endParaRPr lang="en-US" dirty="0"/>
           </a:p>
@@ -2421,7 +2610,7 @@
 </file>
 
 <file path=ppt/slideLayouts/slideLayout9.xml><?xml version="1.0" encoding="utf-8"?>
-<p:sldLayout xmlns:a="http://schemas.openxmlformats.org/drawingml/2006/main" xmlns:r="http://schemas.openxmlformats.org/officeDocument/2006/relationships" xmlns:p="http://schemas.openxmlformats.org/presentationml/2006/main" showMasterSp="0" type="picTx" preserve="1">
+<p:sldLayout xmlns:a="http://schemas.openxmlformats.org/drawingml/2006/main" xmlns:r="http://schemas.openxmlformats.org/officeDocument/2006/relationships" xmlns:p="http://schemas.openxmlformats.org/presentationml/2006/main" type="picTx" preserve="1" showMasterSp="0">
   <p:cSld name="Picture with Caption">
     <p:spTree>
       <p:nvGrpSpPr>
@@ -2619,6 +2808,7 @@
               <a:rPr lang="en-US" smtClean="0"/>
               <a:t>Edit Master text styles</a:t>
             </a:r>
+            <a:endParaRPr lang="en-US" smtClean="0"/>
           </a:p>
         </p:txBody>
       </p:sp>
@@ -2639,7 +2829,6 @@
           <a:p>
             <a:fld id="{C7616CA0-919D-4A49-9C8A-62FDFB3A5183}" type="datetimeFigureOut">
               <a:rPr lang="en-US" dirty="0"/>
-              <a:t>6/11/2026</a:t>
             </a:fld>
             <a:endParaRPr lang="en-US" dirty="0"/>
           </a:p>
@@ -2681,7 +2870,6 @@
           <a:p>
             <a:fld id="{867E5644-1E61-4311-A31E-84CB9C7AA8A9}" type="slidenum">
               <a:rPr lang="en-US" dirty="0"/>
-              <a:t>‹#›</a:t>
             </a:fld>
             <a:endParaRPr lang="en-US" dirty="0"/>
           </a:p>
@@ -2815,6 +3003,7 @@
               <a:rPr lang="en-US" smtClean="0"/>
               <a:t>Edit Master text styles</a:t>
             </a:r>
+            <a:endParaRPr lang="en-US" smtClean="0"/>
           </a:p>
           <a:p>
             <a:pPr lvl="1"/>
@@ -2822,6 +3011,7 @@
               <a:rPr lang="en-US" smtClean="0"/>
               <a:t>Second level</a:t>
             </a:r>
+            <a:endParaRPr lang="en-US" smtClean="0"/>
           </a:p>
           <a:p>
             <a:pPr lvl="2"/>
@@ -2829,6 +3019,7 @@
               <a:rPr lang="en-US" smtClean="0"/>
               <a:t>Third level</a:t>
             </a:r>
+            <a:endParaRPr lang="en-US" smtClean="0"/>
           </a:p>
           <a:p>
             <a:pPr lvl="3"/>
@@ -2836,6 +3027,7 @@
               <a:rPr lang="en-US" smtClean="0"/>
               <a:t>Fourth level</a:t>
             </a:r>
+            <a:endParaRPr lang="en-US" smtClean="0"/>
           </a:p>
           <a:p>
             <a:pPr lvl="4"/>
@@ -2884,8 +3076,6 @@
           <a:p>
             <a:fld id="{90298CD5-6C1E-4009-B41F-6DF62E31D3BE}" type="datetimeFigureOut">
               <a:rPr lang="en-US" dirty="0"/>
-              <a:pPr/>
-              <a:t>6/11/2026</a:t>
             </a:fld>
             <a:endParaRPr lang="en-US" dirty="0"/>
           </a:p>
@@ -2967,8 +3157,6 @@
           <a:p>
             <a:fld id="{4FAB73BC-B049-4115-A692-8D63A059BFB8}" type="slidenum">
               <a:rPr lang="en-US" dirty="0"/>
-              <a:pPr/>
-              <a:t>‹#›</a:t>
             </a:fld>
             <a:endParaRPr lang="en-US" dirty="0"/>
           </a:p>
@@ -3021,9 +3209,10 @@
     <p:sldLayoutId id="2147483654" r:id="rId6"/>
     <p:sldLayoutId id="2147483655" r:id="rId7"/>
     <p:sldLayoutId id="2147483656" r:id="rId8"/>
-    <p:sldLayoutId id="2147483660" r:id="rId9"/>
+    <p:sldLayoutId id="2147483657" r:id="rId9"/>
     <p:sldLayoutId id="2147483658" r:id="rId10"/>
     <p:sldLayoutId id="2147483659" r:id="rId11"/>
+    <p:sldLayoutId id="2147483660" r:id="rId12"/>
   </p:sldLayoutIdLst>
   <p:txStyles>
     <p:titleStyle>
@@ -3074,7 +3263,7 @@
           <a:cs typeface="+mn-cs"/>
         </a:defRPr>
       </a:lvl1pPr>
-      <a:lvl2pPr marL="265176" indent="-137160" algn="l" defTabSz="914400" rtl="0" eaLnBrk="1" latinLnBrk="0" hangingPunct="1">
+      <a:lvl2pPr marL="265430" indent="-137160" algn="l" defTabSz="914400" rtl="0" eaLnBrk="1" latinLnBrk="0" hangingPunct="1">
         <a:lnSpc>
           <a:spcPct val="90000"/>
         </a:lnSpc>
@@ -3098,7 +3287,7 @@
           <a:cs typeface="+mn-cs"/>
         </a:defRPr>
       </a:lvl2pPr>
-      <a:lvl3pPr marL="448056" indent="-137160" algn="l" defTabSz="914400" rtl="0" eaLnBrk="1" latinLnBrk="0" hangingPunct="1">
+      <a:lvl3pPr marL="448310" indent="-137160" algn="l" defTabSz="914400" rtl="0" eaLnBrk="1" latinLnBrk="0" hangingPunct="1">
         <a:lnSpc>
           <a:spcPct val="90000"/>
         </a:lnSpc>
@@ -3194,7 +3383,7 @@
           <a:cs typeface="+mn-cs"/>
         </a:defRPr>
       </a:lvl6pPr>
-      <a:lvl7pPr marL="1060704" indent="-137160" algn="l" defTabSz="914400" rtl="0" eaLnBrk="1" latinLnBrk="0" hangingPunct="1">
+      <a:lvl7pPr marL="1060450" indent="-137160" algn="l" defTabSz="914400" rtl="0" eaLnBrk="1" latinLnBrk="0" hangingPunct="1">
         <a:lnSpc>
           <a:spcPct val="90000"/>
         </a:lnSpc>
@@ -3218,7 +3407,7 @@
           <a:cs typeface="+mn-cs"/>
         </a:defRPr>
       </a:lvl7pPr>
-      <a:lvl8pPr marL="1216152" indent="-137160" algn="l" defTabSz="914400" rtl="0" eaLnBrk="1" latinLnBrk="0" hangingPunct="1">
+      <a:lvl8pPr marL="1216025" indent="-137160" algn="l" defTabSz="914400" rtl="0" eaLnBrk="1" latinLnBrk="0" hangingPunct="1">
         <a:lnSpc>
           <a:spcPct val="90000"/>
         </a:lnSpc>
@@ -3242,7 +3431,7 @@
           <a:cs typeface="+mn-cs"/>
         </a:defRPr>
       </a:lvl8pPr>
-      <a:lvl9pPr marL="1362456" indent="-137160" algn="l" defTabSz="914400" rtl="0" eaLnBrk="1" latinLnBrk="0" hangingPunct="1">
+      <a:lvl9pPr marL="1362710" indent="-137160" algn="l" defTabSz="914400" rtl="0" eaLnBrk="1" latinLnBrk="0" hangingPunct="1">
         <a:lnSpc>
           <a:spcPct val="90000"/>
         </a:lnSpc>
@@ -3432,11 +3621,6 @@
         </p:txBody>
       </p:sp>
     </p:spTree>
-    <p:extLst>
-      <p:ext uri="{BB962C8B-B14F-4D97-AF65-F5344CB8AC3E}">
-        <p14:creationId xmlns:p14="http://schemas.microsoft.com/office/powerpoint/2010/main" val="3104693202"/>
-      </p:ext>
-    </p:extLst>
   </p:cSld>
   <p:clrMapOvr>
     <a:masterClrMapping/>
@@ -3495,7 +3679,7 @@
           </p:nvPr>
         </p:nvPicPr>
         <p:blipFill>
-          <a:blip r:embed="rId2"/>
+          <a:blip r:embed="rId1"/>
           <a:stretch>
             <a:fillRect/>
           </a:stretch>
@@ -3530,11 +3714,6 @@
         </p:txBody>
       </p:sp>
     </p:spTree>
-    <p:extLst>
-      <p:ext uri="{BB962C8B-B14F-4D97-AF65-F5344CB8AC3E}">
-        <p14:creationId xmlns:p14="http://schemas.microsoft.com/office/powerpoint/2010/main" val="1408522353"/>
-      </p:ext>
-    </p:extLst>
   </p:cSld>
   <p:clrMapOvr>
     <a:masterClrMapping/>
@@ -3593,7 +3772,7 @@
           </p:nvPr>
         </p:nvPicPr>
         <p:blipFill>
-          <a:blip r:embed="rId2"/>
+          <a:blip r:embed="rId1"/>
           <a:stretch>
             <a:fillRect/>
           </a:stretch>
@@ -3628,11 +3807,6 @@
         </p:txBody>
       </p:sp>
     </p:spTree>
-    <p:extLst>
-      <p:ext uri="{BB962C8B-B14F-4D97-AF65-F5344CB8AC3E}">
-        <p14:creationId xmlns:p14="http://schemas.microsoft.com/office/powerpoint/2010/main" val="1279074256"/>
-      </p:ext>
-    </p:extLst>
   </p:cSld>
   <p:clrMapOvr>
     <a:masterClrMapping/>
@@ -3676,7 +3850,7 @@
               <a:rPr lang="bg-BG" dirty="0" smtClean="0"/>
               <a:t>Анализ на данни</a:t>
             </a:r>
-            <a:endParaRPr lang="en-US" dirty="0"/>
+            <a:endParaRPr lang="bg-BG" dirty="0" smtClean="0"/>
           </a:p>
         </p:txBody>
       </p:sp>
@@ -3700,11 +3874,6 @@
         </p:txBody>
       </p:sp>
     </p:spTree>
-    <p:extLst>
-      <p:ext uri="{BB962C8B-B14F-4D97-AF65-F5344CB8AC3E}">
-        <p14:creationId xmlns:p14="http://schemas.microsoft.com/office/powerpoint/2010/main" val="3267621586"/>
-      </p:ext>
-    </p:extLst>
   </p:cSld>
   <p:clrMapOvr>
     <a:masterClrMapping/>
@@ -3721,17 +3890,10 @@
         <p:cNvGrpSpPr/>
         <p:nvPr/>
       </p:nvGrpSpPr>
-      <p:grpSpPr>
-        <a:xfrm>
-          <a:off x="0" y="0"/>
-          <a:ext cx="0" cy="0"/>
-          <a:chOff x="0" y="0"/>
-          <a:chExt cx="0" cy="0"/>
-        </a:xfrm>
-      </p:grpSpPr>
-      <p:sp>
-        <p:nvSpPr>
-          <p:cNvPr id="2" name="Title 1"/>
+      <p:grpSpPr/>
+      <p:sp>
+        <p:nvSpPr>
+          <p:cNvPr id="4" name="Title 3"/>
           <p:cNvSpPr>
             <a:spLocks noGrp="1"/>
           </p:cNvSpPr>
@@ -3742,44 +3904,42 @@
         <p:spPr/>
         <p:txBody>
           <a:bodyPr/>
-          <a:lstStyle/>
-          <a:p>
-            <a:r>
-              <a:rPr lang="bg-BG" dirty="0" smtClean="0"/>
-              <a:t>предизвикателства</a:t>
-            </a:r>
-            <a:endParaRPr lang="en-US" dirty="0"/>
-          </a:p>
-        </p:txBody>
-      </p:sp>
-      <p:sp>
-        <p:nvSpPr>
-          <p:cNvPr id="3" name="Content Placeholder 2"/>
-          <p:cNvSpPr>
-            <a:spLocks noGrp="1"/>
-          </p:cNvSpPr>
+          <a:p>
+            <a:r>
+              <a:rPr lang="bg-BG" altLang="en-GB"/>
+              <a:t>Брой по години</a:t>
+            </a:r>
+            <a:endParaRPr lang="bg-BG" altLang="en-GB"/>
+          </a:p>
+        </p:txBody>
+      </p:sp>
+      <p:pic>
+        <p:nvPicPr>
+          <p:cNvPr id="6" name="Content Placeholder 5" descr="total_marriages_and_births"/>
+          <p:cNvPicPr>
+            <a:picLocks noChangeAspect="1"/>
+          </p:cNvPicPr>
           <p:nvPr>
             <p:ph idx="1"/>
           </p:nvPr>
-        </p:nvSpPr>
-        <p:spPr/>
-        <p:txBody>
-          <a:bodyPr/>
-          <a:lstStyle/>
-          <a:p>
-            <a:pPr marL="0" indent="0">
-              <a:buNone/>
-            </a:pPr>
-            <a:endParaRPr lang="en-US" dirty="0"/>
-          </a:p>
-        </p:txBody>
-      </p:sp>
+        </p:nvPicPr>
+        <p:blipFill>
+          <a:blip r:embed="rId1"/>
+          <a:stretch>
+            <a:fillRect/>
+          </a:stretch>
+        </p:blipFill>
+        <p:spPr>
+          <a:xfrm>
+            <a:off x="1860550" y="2286000"/>
+            <a:ext cx="8046085" cy="4023360"/>
+          </a:xfrm>
+          <a:prstGeom prst="rect">
+            <a:avLst/>
+          </a:prstGeom>
+        </p:spPr>
+      </p:pic>
     </p:spTree>
-    <p:extLst>
-      <p:ext uri="{BB962C8B-B14F-4D97-AF65-F5344CB8AC3E}">
-        <p14:creationId xmlns:p14="http://schemas.microsoft.com/office/powerpoint/2010/main" val="466157789"/>
-      </p:ext>
-    </p:extLst>
   </p:cSld>
   <p:clrMapOvr>
     <a:masterClrMapping/>
@@ -3796,6 +3956,548 @@
         <p:cNvGrpSpPr/>
         <p:nvPr/>
       </p:nvGrpSpPr>
+      <p:grpSpPr/>
+      <p:sp>
+        <p:nvSpPr>
+          <p:cNvPr id="4" name="Title 3"/>
+          <p:cNvSpPr>
+            <a:spLocks noGrp="1"/>
+          </p:cNvSpPr>
+          <p:nvPr>
+            <p:ph type="title"/>
+          </p:nvPr>
+        </p:nvSpPr>
+        <p:spPr/>
+        <p:txBody>
+          <a:bodyPr/>
+          <a:p>
+            <a:r>
+              <a:rPr lang="bg-BG" altLang="en-US"/>
+              <a:t>брой по години</a:t>
+            </a:r>
+            <a:endParaRPr lang="bg-BG" altLang="en-US"/>
+          </a:p>
+        </p:txBody>
+      </p:sp>
+      <p:sp>
+        <p:nvSpPr>
+          <p:cNvPr id="6" name="Text Placeholder 5"/>
+          <p:cNvSpPr>
+            <a:spLocks noGrp="1"/>
+          </p:cNvSpPr>
+          <p:nvPr>
+            <p:ph type="body" idx="1"/>
+          </p:nvPr>
+        </p:nvSpPr>
+        <p:spPr/>
+        <p:txBody>
+          <a:bodyPr/>
+          <a:p>
+            <a:r>
+              <a:rPr lang="bg-BG" altLang="en-GB"/>
+              <a:t>Градове</a:t>
+            </a:r>
+            <a:endParaRPr lang="bg-BG" altLang="en-GB"/>
+          </a:p>
+        </p:txBody>
+      </p:sp>
+      <p:pic>
+        <p:nvPicPr>
+          <p:cNvPr id="10" name="Content Placeholder 9" descr="urban_marriages_and_births"/>
+          <p:cNvPicPr>
+            <a:picLocks noChangeAspect="1"/>
+          </p:cNvPicPr>
+          <p:nvPr>
+            <p:ph sz="half" idx="2"/>
+          </p:nvPr>
+        </p:nvPicPr>
+        <p:blipFill>
+          <a:blip r:embed="rId1"/>
+          <a:stretch>
+            <a:fillRect/>
+          </a:stretch>
+        </p:blipFill>
+        <p:spPr>
+          <a:xfrm>
+            <a:off x="1024255" y="3449320"/>
+            <a:ext cx="4754880" cy="2377440"/>
+          </a:xfrm>
+          <a:prstGeom prst="rect">
+            <a:avLst/>
+          </a:prstGeom>
+        </p:spPr>
+      </p:pic>
+      <p:sp>
+        <p:nvSpPr>
+          <p:cNvPr id="8" name="Text Placeholder 7"/>
+          <p:cNvSpPr>
+            <a:spLocks noGrp="1"/>
+          </p:cNvSpPr>
+          <p:nvPr>
+            <p:ph type="body" sz="quarter" idx="3"/>
+          </p:nvPr>
+        </p:nvSpPr>
+        <p:spPr/>
+        <p:txBody>
+          <a:bodyPr/>
+          <a:p>
+            <a:r>
+              <a:rPr lang="bg-BG" altLang="en-GB"/>
+              <a:t>Села</a:t>
+            </a:r>
+            <a:endParaRPr lang="bg-BG" altLang="en-GB"/>
+          </a:p>
+        </p:txBody>
+      </p:sp>
+      <p:pic>
+        <p:nvPicPr>
+          <p:cNvPr id="11" name="Content Placeholder 10" descr="rural_marriages_and_births"/>
+          <p:cNvPicPr>
+            <a:picLocks noChangeAspect="1"/>
+          </p:cNvPicPr>
+          <p:nvPr>
+            <p:ph sz="quarter" idx="4"/>
+          </p:nvPr>
+        </p:nvPicPr>
+        <p:blipFill>
+          <a:blip r:embed="rId2"/>
+          <a:stretch>
+            <a:fillRect/>
+          </a:stretch>
+        </p:blipFill>
+        <p:spPr>
+          <a:xfrm>
+            <a:off x="5990590" y="3449320"/>
+            <a:ext cx="4754880" cy="2377440"/>
+          </a:xfrm>
+          <a:prstGeom prst="rect">
+            <a:avLst/>
+          </a:prstGeom>
+        </p:spPr>
+      </p:pic>
+    </p:spTree>
+  </p:cSld>
+  <p:clrMapOvr>
+    <a:masterClrMapping/>
+  </p:clrMapOvr>
+</p:sld>
+</file>
+
+<file path=ppt/slides/slide15.xml><?xml version="1.0" encoding="utf-8"?>
+<p:sld xmlns:a="http://schemas.openxmlformats.org/drawingml/2006/main" xmlns:r="http://schemas.openxmlformats.org/officeDocument/2006/relationships" xmlns:p="http://schemas.openxmlformats.org/presentationml/2006/main">
+  <p:cSld>
+    <p:spTree>
+      <p:nvGrpSpPr>
+        <p:cNvPr id="1" name=""/>
+        <p:cNvGrpSpPr/>
+        <p:nvPr/>
+      </p:nvGrpSpPr>
+      <p:grpSpPr/>
+      <p:sp>
+        <p:nvSpPr>
+          <p:cNvPr id="4" name="Title 3"/>
+          <p:cNvSpPr>
+            <a:spLocks noGrp="1"/>
+          </p:cNvSpPr>
+          <p:nvPr>
+            <p:ph type="title"/>
+          </p:nvPr>
+        </p:nvSpPr>
+        <p:spPr/>
+        <p:txBody>
+          <a:bodyPr/>
+          <a:p>
+            <a:r>
+              <a:rPr lang="bg-BG" altLang="en-US"/>
+              <a:t>Лаг 5 години</a:t>
+            </a:r>
+            <a:endParaRPr lang="bg-BG" altLang="en-US"/>
+          </a:p>
+        </p:txBody>
+      </p:sp>
+      <p:pic>
+        <p:nvPicPr>
+          <p:cNvPr id="2" name="Content Placeholder 1" descr="total_lag"/>
+          <p:cNvPicPr>
+            <a:picLocks noChangeAspect="1"/>
+          </p:cNvPicPr>
+          <p:nvPr>
+            <p:ph idx="1"/>
+          </p:nvPr>
+        </p:nvPicPr>
+        <p:blipFill>
+          <a:blip r:embed="rId1"/>
+          <a:stretch>
+            <a:fillRect/>
+          </a:stretch>
+        </p:blipFill>
+        <p:spPr>
+          <a:xfrm>
+            <a:off x="1024255" y="2561590"/>
+            <a:ext cx="9719945" cy="3471545"/>
+          </a:xfrm>
+          <a:prstGeom prst="rect">
+            <a:avLst/>
+          </a:prstGeom>
+        </p:spPr>
+      </p:pic>
+    </p:spTree>
+  </p:cSld>
+  <p:clrMapOvr>
+    <a:masterClrMapping/>
+  </p:clrMapOvr>
+</p:sld>
+</file>
+
+<file path=ppt/slides/slide16.xml><?xml version="1.0" encoding="utf-8"?>
+<p:sld xmlns:a="http://schemas.openxmlformats.org/drawingml/2006/main" xmlns:r="http://schemas.openxmlformats.org/officeDocument/2006/relationships" xmlns:p="http://schemas.openxmlformats.org/presentationml/2006/main">
+  <p:cSld>
+    <p:spTree>
+      <p:nvGrpSpPr>
+        <p:cNvPr id="1" name=""/>
+        <p:cNvGrpSpPr/>
+        <p:nvPr/>
+      </p:nvGrpSpPr>
+      <p:grpSpPr/>
+      <p:sp>
+        <p:nvSpPr>
+          <p:cNvPr id="4" name="Title 3"/>
+          <p:cNvSpPr>
+            <a:spLocks noGrp="1"/>
+          </p:cNvSpPr>
+          <p:nvPr>
+            <p:ph type="title"/>
+          </p:nvPr>
+        </p:nvSpPr>
+        <p:spPr/>
+        <p:txBody>
+          <a:bodyPr/>
+          <a:p>
+            <a:r>
+              <a:rPr lang="bg-BG" altLang="en-US"/>
+              <a:t>ЛАг 5 години</a:t>
+            </a:r>
+            <a:endParaRPr lang="bg-BG" altLang="en-US"/>
+          </a:p>
+        </p:txBody>
+      </p:sp>
+      <p:sp>
+        <p:nvSpPr>
+          <p:cNvPr id="6" name="Text Placeholder 5"/>
+          <p:cNvSpPr>
+            <a:spLocks noGrp="1"/>
+          </p:cNvSpPr>
+          <p:nvPr>
+            <p:ph type="body" idx="1"/>
+          </p:nvPr>
+        </p:nvSpPr>
+        <p:spPr/>
+        <p:txBody>
+          <a:bodyPr/>
+          <a:p>
+            <a:r>
+              <a:rPr lang="bg-BG" altLang="en-GB"/>
+              <a:t>Градове</a:t>
+            </a:r>
+            <a:endParaRPr lang="bg-BG" altLang="en-GB"/>
+          </a:p>
+        </p:txBody>
+      </p:sp>
+      <p:pic>
+        <p:nvPicPr>
+          <p:cNvPr id="2" name="Content Placeholder 1" descr="urban_lag"/>
+          <p:cNvPicPr>
+            <a:picLocks noChangeAspect="1"/>
+          </p:cNvPicPr>
+          <p:nvPr>
+            <p:ph sz="half" idx="2"/>
+          </p:nvPr>
+        </p:nvPicPr>
+        <p:blipFill>
+          <a:blip r:embed="rId1"/>
+          <a:stretch>
+            <a:fillRect/>
+          </a:stretch>
+        </p:blipFill>
+        <p:spPr>
+          <a:xfrm>
+            <a:off x="1024255" y="3789045"/>
+            <a:ext cx="4754880" cy="1697990"/>
+          </a:xfrm>
+          <a:prstGeom prst="rect">
+            <a:avLst/>
+          </a:prstGeom>
+        </p:spPr>
+      </p:pic>
+      <p:sp>
+        <p:nvSpPr>
+          <p:cNvPr id="8" name="Text Placeholder 7"/>
+          <p:cNvSpPr>
+            <a:spLocks noGrp="1"/>
+          </p:cNvSpPr>
+          <p:nvPr>
+            <p:ph type="body" sz="quarter" idx="3"/>
+          </p:nvPr>
+        </p:nvSpPr>
+        <p:spPr/>
+        <p:txBody>
+          <a:bodyPr/>
+          <a:p>
+            <a:r>
+              <a:rPr lang="bg-BG" altLang="en-GB"/>
+              <a:t>Села</a:t>
+            </a:r>
+            <a:endParaRPr lang="bg-BG" altLang="en-GB"/>
+          </a:p>
+        </p:txBody>
+      </p:sp>
+      <p:pic>
+        <p:nvPicPr>
+          <p:cNvPr id="3" name="Content Placeholder 2" descr="rural_lag"/>
+          <p:cNvPicPr>
+            <a:picLocks noChangeAspect="1"/>
+          </p:cNvPicPr>
+          <p:nvPr>
+            <p:ph sz="quarter" idx="4"/>
+          </p:nvPr>
+        </p:nvPicPr>
+        <p:blipFill>
+          <a:blip r:embed="rId2"/>
+          <a:stretch>
+            <a:fillRect/>
+          </a:stretch>
+        </p:blipFill>
+        <p:spPr>
+          <a:xfrm>
+            <a:off x="5990590" y="3789045"/>
+            <a:ext cx="4754880" cy="1697990"/>
+          </a:xfrm>
+          <a:prstGeom prst="rect">
+            <a:avLst/>
+          </a:prstGeom>
+        </p:spPr>
+      </p:pic>
+    </p:spTree>
+  </p:cSld>
+  <p:clrMapOvr>
+    <a:masterClrMapping/>
+  </p:clrMapOvr>
+</p:sld>
+</file>
+
+<file path=ppt/slides/slide17.xml><?xml version="1.0" encoding="utf-8"?>
+<p:sld xmlns:a="http://schemas.openxmlformats.org/drawingml/2006/main" xmlns:r="http://schemas.openxmlformats.org/officeDocument/2006/relationships" xmlns:p="http://schemas.openxmlformats.org/presentationml/2006/main">
+  <p:cSld>
+    <p:spTree>
+      <p:nvGrpSpPr>
+        <p:cNvPr id="1" name=""/>
+        <p:cNvGrpSpPr/>
+        <p:nvPr/>
+      </p:nvGrpSpPr>
+      <p:grpSpPr/>
+      <p:sp>
+        <p:nvSpPr>
+          <p:cNvPr id="4" name="Title 3"/>
+          <p:cNvSpPr>
+            <a:spLocks noGrp="1"/>
+          </p:cNvSpPr>
+          <p:nvPr>
+            <p:ph type="title"/>
+          </p:nvPr>
+        </p:nvSpPr>
+        <p:spPr/>
+        <p:txBody>
+          <a:bodyPr/>
+          <a:p>
+            <a:r>
+              <a:rPr lang="bg-BG" altLang="en-US"/>
+              <a:t>Процент извънбрачни</a:t>
+            </a:r>
+            <a:endParaRPr lang="bg-BG" altLang="en-US"/>
+          </a:p>
+        </p:txBody>
+      </p:sp>
+      <p:pic>
+        <p:nvPicPr>
+          <p:cNvPr id="2" name="Content Placeholder 1" descr="total_nonmarital_share"/>
+          <p:cNvPicPr>
+            <a:picLocks noChangeAspect="1"/>
+          </p:cNvPicPr>
+          <p:nvPr>
+            <p:ph idx="1"/>
+          </p:nvPr>
+        </p:nvPicPr>
+        <p:blipFill>
+          <a:blip r:embed="rId1"/>
+          <a:stretch>
+            <a:fillRect/>
+          </a:stretch>
+        </p:blipFill>
+        <p:spPr>
+          <a:xfrm>
+            <a:off x="1860550" y="2286000"/>
+            <a:ext cx="8046085" cy="4023360"/>
+          </a:xfrm>
+          <a:prstGeom prst="rect">
+            <a:avLst/>
+          </a:prstGeom>
+        </p:spPr>
+      </p:pic>
+    </p:spTree>
+  </p:cSld>
+  <p:clrMapOvr>
+    <a:masterClrMapping/>
+  </p:clrMapOvr>
+</p:sld>
+</file>
+
+<file path=ppt/slides/slide18.xml><?xml version="1.0" encoding="utf-8"?>
+<p:sld xmlns:a="http://schemas.openxmlformats.org/drawingml/2006/main" xmlns:r="http://schemas.openxmlformats.org/officeDocument/2006/relationships" xmlns:p="http://schemas.openxmlformats.org/presentationml/2006/main">
+  <p:cSld>
+    <p:spTree>
+      <p:nvGrpSpPr>
+        <p:cNvPr id="1" name=""/>
+        <p:cNvGrpSpPr/>
+        <p:nvPr/>
+      </p:nvGrpSpPr>
+      <p:grpSpPr/>
+      <p:sp>
+        <p:nvSpPr>
+          <p:cNvPr id="4" name="Title 3"/>
+          <p:cNvSpPr>
+            <a:spLocks noGrp="1"/>
+          </p:cNvSpPr>
+          <p:nvPr>
+            <p:ph type="title"/>
+          </p:nvPr>
+        </p:nvSpPr>
+        <p:spPr/>
+        <p:txBody>
+          <a:bodyPr/>
+          <a:p>
+            <a:r>
+              <a:rPr lang="bg-BG" altLang="en-US">
+                <a:sym typeface="+mn-ea"/>
+              </a:rPr>
+              <a:t>Процент извънбрачни</a:t>
+            </a:r>
+            <a:endParaRPr lang="bg-BG" altLang="en-US"/>
+          </a:p>
+        </p:txBody>
+      </p:sp>
+      <p:sp>
+        <p:nvSpPr>
+          <p:cNvPr id="6" name="Text Placeholder 5"/>
+          <p:cNvSpPr>
+            <a:spLocks noGrp="1"/>
+          </p:cNvSpPr>
+          <p:nvPr>
+            <p:ph type="body" idx="1"/>
+          </p:nvPr>
+        </p:nvSpPr>
+        <p:spPr/>
+        <p:txBody>
+          <a:bodyPr/>
+          <a:p>
+            <a:r>
+              <a:rPr lang="bg-BG" altLang="en-GB"/>
+              <a:t>Градове</a:t>
+            </a:r>
+            <a:endParaRPr lang="bg-BG" altLang="en-GB"/>
+          </a:p>
+        </p:txBody>
+      </p:sp>
+      <p:pic>
+        <p:nvPicPr>
+          <p:cNvPr id="2" name="Content Placeholder 1" descr="urban_nonmarital_share"/>
+          <p:cNvPicPr>
+            <a:picLocks noChangeAspect="1"/>
+          </p:cNvPicPr>
+          <p:nvPr>
+            <p:ph sz="half" idx="2"/>
+          </p:nvPr>
+        </p:nvPicPr>
+        <p:blipFill>
+          <a:blip r:embed="rId1"/>
+          <a:stretch>
+            <a:fillRect/>
+          </a:stretch>
+        </p:blipFill>
+        <p:spPr>
+          <a:xfrm>
+            <a:off x="1024255" y="3449320"/>
+            <a:ext cx="4754880" cy="2377440"/>
+          </a:xfrm>
+          <a:prstGeom prst="rect">
+            <a:avLst/>
+          </a:prstGeom>
+        </p:spPr>
+      </p:pic>
+      <p:sp>
+        <p:nvSpPr>
+          <p:cNvPr id="8" name="Text Placeholder 7"/>
+          <p:cNvSpPr>
+            <a:spLocks noGrp="1"/>
+          </p:cNvSpPr>
+          <p:nvPr>
+            <p:ph type="body" sz="quarter" idx="3"/>
+          </p:nvPr>
+        </p:nvSpPr>
+        <p:spPr/>
+        <p:txBody>
+          <a:bodyPr/>
+          <a:p>
+            <a:r>
+              <a:rPr lang="bg-BG" altLang="en-GB"/>
+              <a:t>Села</a:t>
+            </a:r>
+            <a:endParaRPr lang="bg-BG" altLang="en-GB"/>
+          </a:p>
+        </p:txBody>
+      </p:sp>
+      <p:pic>
+        <p:nvPicPr>
+          <p:cNvPr id="3" name="Content Placeholder 2" descr="rural_nonmarital_share"/>
+          <p:cNvPicPr>
+            <a:picLocks noChangeAspect="1"/>
+          </p:cNvPicPr>
+          <p:nvPr>
+            <p:ph sz="quarter" idx="4"/>
+          </p:nvPr>
+        </p:nvPicPr>
+        <p:blipFill>
+          <a:blip r:embed="rId2"/>
+          <a:stretch>
+            <a:fillRect/>
+          </a:stretch>
+        </p:blipFill>
+        <p:spPr>
+          <a:xfrm>
+            <a:off x="5990590" y="3449320"/>
+            <a:ext cx="4754880" cy="2377440"/>
+          </a:xfrm>
+          <a:prstGeom prst="rect">
+            <a:avLst/>
+          </a:prstGeom>
+        </p:spPr>
+      </p:pic>
+    </p:spTree>
+  </p:cSld>
+  <p:clrMapOvr>
+    <a:masterClrMapping/>
+  </p:clrMapOvr>
+</p:sld>
+</file>
+
+<file path=ppt/slides/slide19.xml><?xml version="1.0" encoding="utf-8"?>
+<p:sld xmlns:a="http://schemas.openxmlformats.org/drawingml/2006/main" xmlns:r="http://schemas.openxmlformats.org/officeDocument/2006/relationships" xmlns:p="http://schemas.openxmlformats.org/presentationml/2006/main">
+  <p:cSld>
+    <p:spTree>
+      <p:nvGrpSpPr>
+        <p:cNvPr id="1" name=""/>
+        <p:cNvGrpSpPr/>
+        <p:nvPr/>
+      </p:nvGrpSpPr>
       <p:grpSpPr>
         <a:xfrm>
           <a:off x="0" y="0"/>
@@ -3821,37 +4523,35 @@
           <a:p>
             <a:r>
               <a:rPr lang="bg-BG" dirty="0" smtClean="0"/>
-              <a:t>Заключение</a:t>
-            </a:r>
-            <a:endParaRPr lang="en-US" dirty="0"/>
-          </a:p>
-        </p:txBody>
-      </p:sp>
-      <p:sp>
-        <p:nvSpPr>
-          <p:cNvPr id="3" name="Text Placeholder 2"/>
-          <p:cNvSpPr>
-            <a:spLocks noGrp="1"/>
-          </p:cNvSpPr>
-          <p:nvPr>
-            <p:ph type="body" idx="1"/>
-          </p:nvPr>
-        </p:nvSpPr>
-        <p:spPr/>
-        <p:txBody>
-          <a:bodyPr/>
-          <a:lstStyle/>
-          <a:p>
-            <a:endParaRPr lang="en-US"/>
+              <a:t>предизвикателства</a:t>
+            </a:r>
+            <a:endParaRPr lang="en-US" dirty="0"/>
+          </a:p>
+        </p:txBody>
+      </p:sp>
+      <p:sp>
+        <p:nvSpPr>
+          <p:cNvPr id="3" name="Content Placeholder 2"/>
+          <p:cNvSpPr>
+            <a:spLocks noGrp="1"/>
+          </p:cNvSpPr>
+          <p:nvPr>
+            <p:ph idx="1"/>
+          </p:nvPr>
+        </p:nvSpPr>
+        <p:spPr/>
+        <p:txBody>
+          <a:bodyPr/>
+          <a:lstStyle/>
+          <a:p>
+            <a:pPr marL="0" indent="0">
+              <a:buNone/>
+            </a:pPr>
+            <a:endParaRPr lang="en-US" dirty="0"/>
           </a:p>
         </p:txBody>
       </p:sp>
     </p:spTree>
-    <p:extLst>
-      <p:ext uri="{BB962C8B-B14F-4D97-AF65-F5344CB8AC3E}">
-        <p14:creationId xmlns:p14="http://schemas.microsoft.com/office/powerpoint/2010/main" val="3156158096"/>
-      </p:ext>
-    </p:extLst>
   </p:cSld>
   <p:clrMapOvr>
     <a:masterClrMapping/>
@@ -3919,11 +4619,73 @@
         </p:txBody>
       </p:sp>
     </p:spTree>
-    <p:extLst>
-      <p:ext uri="{BB962C8B-B14F-4D97-AF65-F5344CB8AC3E}">
-        <p14:creationId xmlns:p14="http://schemas.microsoft.com/office/powerpoint/2010/main" val="1589744450"/>
-      </p:ext>
-    </p:extLst>
+  </p:cSld>
+  <p:clrMapOvr>
+    <a:masterClrMapping/>
+  </p:clrMapOvr>
+</p:sld>
+</file>
+
+<file path=ppt/slides/slide20.xml><?xml version="1.0" encoding="utf-8"?>
+<p:sld xmlns:a="http://schemas.openxmlformats.org/drawingml/2006/main" xmlns:r="http://schemas.openxmlformats.org/officeDocument/2006/relationships" xmlns:p="http://schemas.openxmlformats.org/presentationml/2006/main">
+  <p:cSld>
+    <p:spTree>
+      <p:nvGrpSpPr>
+        <p:cNvPr id="1" name=""/>
+        <p:cNvGrpSpPr/>
+        <p:nvPr/>
+      </p:nvGrpSpPr>
+      <p:grpSpPr>
+        <a:xfrm>
+          <a:off x="0" y="0"/>
+          <a:ext cx="0" cy="0"/>
+          <a:chOff x="0" y="0"/>
+          <a:chExt cx="0" cy="0"/>
+        </a:xfrm>
+      </p:grpSpPr>
+      <p:sp>
+        <p:nvSpPr>
+          <p:cNvPr id="2" name="Title 1"/>
+          <p:cNvSpPr>
+            <a:spLocks noGrp="1"/>
+          </p:cNvSpPr>
+          <p:nvPr>
+            <p:ph type="title"/>
+          </p:nvPr>
+        </p:nvSpPr>
+        <p:spPr/>
+        <p:txBody>
+          <a:bodyPr/>
+          <a:lstStyle/>
+          <a:p>
+            <a:r>
+              <a:rPr lang="bg-BG" dirty="0" smtClean="0"/>
+              <a:t>Заключение</a:t>
+            </a:r>
+            <a:endParaRPr lang="en-US" dirty="0"/>
+          </a:p>
+        </p:txBody>
+      </p:sp>
+      <p:sp>
+        <p:nvSpPr>
+          <p:cNvPr id="3" name="Text Placeholder 2"/>
+          <p:cNvSpPr>
+            <a:spLocks noGrp="1"/>
+          </p:cNvSpPr>
+          <p:nvPr>
+            <p:ph type="body" idx="1"/>
+          </p:nvPr>
+        </p:nvSpPr>
+        <p:spPr/>
+        <p:txBody>
+          <a:bodyPr/>
+          <a:lstStyle/>
+          <a:p>
+            <a:endParaRPr lang="en-US"/>
+          </a:p>
+        </p:txBody>
+      </p:sp>
+    </p:spTree>
   </p:cSld>
   <p:clrMapOvr>
     <a:masterClrMapping/>
@@ -3995,11 +4757,6 @@
         </p:txBody>
       </p:sp>
     </p:spTree>
-    <p:extLst>
-      <p:ext uri="{BB962C8B-B14F-4D97-AF65-F5344CB8AC3E}">
-        <p14:creationId xmlns:p14="http://schemas.microsoft.com/office/powerpoint/2010/main" val="182597485"/>
-      </p:ext>
-    </p:extLst>
   </p:cSld>
   <p:clrMapOvr>
     <a:masterClrMapping/>
@@ -4067,11 +4824,6 @@
         </p:txBody>
       </p:sp>
     </p:spTree>
-    <p:extLst>
-      <p:ext uri="{BB962C8B-B14F-4D97-AF65-F5344CB8AC3E}">
-        <p14:creationId xmlns:p14="http://schemas.microsoft.com/office/powerpoint/2010/main" val="2884314778"/>
-      </p:ext>
-    </p:extLst>
   </p:cSld>
   <p:clrMapOvr>
     <a:masterClrMapping/>
@@ -4195,7 +4947,7 @@
           </p:nvPr>
         </p:nvPicPr>
         <p:blipFill>
-          <a:blip r:embed="rId2"/>
+          <a:blip r:embed="rId1"/>
           <a:stretch>
             <a:fillRect/>
           </a:stretch>
@@ -4219,7 +4971,7 @@
           <p:nvPr/>
         </p:nvPicPr>
         <p:blipFill>
-          <a:blip r:embed="rId3"/>
+          <a:blip r:embed="rId2"/>
           <a:stretch>
             <a:fillRect/>
           </a:stretch>
@@ -4235,11 +4987,6 @@
         </p:spPr>
       </p:pic>
     </p:spTree>
-    <p:extLst>
-      <p:ext uri="{BB962C8B-B14F-4D97-AF65-F5344CB8AC3E}">
-        <p14:creationId xmlns:p14="http://schemas.microsoft.com/office/powerpoint/2010/main" val="1810723077"/>
-      </p:ext>
-    </p:extLst>
   </p:cSld>
   <p:clrMapOvr>
     <a:masterClrMapping/>
@@ -4319,45 +5066,50 @@
               <a:rPr lang="bg-BG" dirty="0" smtClean="0"/>
               <a:t>Има начални редове</a:t>
             </a:r>
-          </a:p>
-          <a:p>
-            <a:pPr marL="128016" lvl="1" indent="0">
+            <a:endParaRPr lang="bg-BG" dirty="0" smtClean="0"/>
+          </a:p>
+          <a:p>
+            <a:pPr marL="128270" lvl="1" indent="0">
               <a:buNone/>
             </a:pPr>
             <a:r>
               <a:rPr lang="bg-BG" dirty="0" smtClean="0"/>
               <a:t>Данните не са подредени</a:t>
             </a:r>
-          </a:p>
-          <a:p>
-            <a:pPr marL="128016" lvl="1" indent="0">
+            <a:endParaRPr lang="bg-BG" dirty="0" smtClean="0"/>
+          </a:p>
+          <a:p>
+            <a:pPr marL="128270" lvl="1" indent="0">
               <a:buNone/>
             </a:pPr>
             <a:r>
               <a:rPr lang="bg-BG" dirty="0" smtClean="0"/>
               <a:t>Стойностите отговарят на два фактора</a:t>
             </a:r>
-          </a:p>
-          <a:p>
-            <a:pPr marL="128016" lvl="1" indent="0">
+            <a:endParaRPr lang="bg-BG" dirty="0" smtClean="0"/>
+          </a:p>
+          <a:p>
+            <a:pPr marL="128270" lvl="1" indent="0">
               <a:buNone/>
             </a:pPr>
             <a:r>
               <a:rPr lang="bg-BG" dirty="0" smtClean="0"/>
               <a:t>Включени общини</a:t>
             </a:r>
-          </a:p>
-          <a:p>
-            <a:pPr marL="128016" lvl="1" indent="0">
+            <a:endParaRPr lang="bg-BG" dirty="0" smtClean="0"/>
+          </a:p>
+          <a:p>
+            <a:pPr marL="128270" lvl="1" indent="0">
               <a:buNone/>
             </a:pPr>
             <a:r>
               <a:rPr lang="bg-BG" dirty="0" smtClean="0"/>
               <a:t>Областите имат община със същото име</a:t>
             </a:r>
-          </a:p>
-          <a:p>
-            <a:pPr marL="128016" lvl="1" indent="0">
+            <a:endParaRPr lang="bg-BG" dirty="0" smtClean="0"/>
+          </a:p>
+          <a:p>
+            <a:pPr marL="128270" lvl="1" indent="0">
               <a:buNone/>
             </a:pPr>
             <a:r>
@@ -4367,7 +5119,7 @@
             <a:endParaRPr lang="en-US" dirty="0" smtClean="0"/>
           </a:p>
           <a:p>
-            <a:pPr marL="128016" lvl="1" indent="0">
+            <a:pPr marL="128270" lvl="1" indent="0">
               <a:buNone/>
             </a:pPr>
             <a:r>
@@ -4387,11 +5139,6 @@
         </p:txBody>
       </p:sp>
     </p:spTree>
-    <p:extLst>
-      <p:ext uri="{BB962C8B-B14F-4D97-AF65-F5344CB8AC3E}">
-        <p14:creationId xmlns:p14="http://schemas.microsoft.com/office/powerpoint/2010/main" val="3129674145"/>
-      </p:ext>
-    </p:extLst>
   </p:cSld>
   <p:clrMapOvr>
     <a:masterClrMapping/>
@@ -4469,6 +5216,7 @@
               <a:rPr lang="bg-BG" dirty="0" smtClean="0"/>
               <a:t>Помощни методи</a:t>
             </a:r>
+            <a:endParaRPr lang="bg-BG" dirty="0" smtClean="0"/>
           </a:p>
           <a:p>
             <a:r>
@@ -4505,6 +5253,7 @@
               <a:rPr lang="bg-BG" dirty="0" smtClean="0"/>
               <a:t>по метрики</a:t>
             </a:r>
+            <a:endParaRPr lang="bg-BG" dirty="0" smtClean="0"/>
           </a:p>
           <a:p>
             <a:r>
@@ -4524,7 +5273,7 @@
           <p:nvPr/>
         </p:nvPicPr>
         <p:blipFill>
-          <a:blip r:embed="rId2"/>
+          <a:blip r:embed="rId1"/>
           <a:stretch>
             <a:fillRect/>
           </a:stretch>
@@ -4540,11 +5289,6 @@
         </p:spPr>
       </p:pic>
     </p:spTree>
-    <p:extLst>
-      <p:ext uri="{BB962C8B-B14F-4D97-AF65-F5344CB8AC3E}">
-        <p14:creationId xmlns:p14="http://schemas.microsoft.com/office/powerpoint/2010/main" val="363684045"/>
-      </p:ext>
-    </p:extLst>
   </p:cSld>
   <p:clrMapOvr>
     <a:masterClrMapping/>
@@ -4607,7 +5351,7 @@
           </p:nvPr>
         </p:nvPicPr>
         <p:blipFill>
-          <a:blip r:embed="rId2"/>
+          <a:blip r:embed="rId1"/>
           <a:stretch>
             <a:fillRect/>
           </a:stretch>
@@ -4642,11 +5386,6 @@
         </p:txBody>
       </p:sp>
     </p:spTree>
-    <p:extLst>
-      <p:ext uri="{BB962C8B-B14F-4D97-AF65-F5344CB8AC3E}">
-        <p14:creationId xmlns:p14="http://schemas.microsoft.com/office/powerpoint/2010/main" val="190924476"/>
-      </p:ext>
-    </p:extLst>
   </p:cSld>
   <p:clrMapOvr>
     <a:masterClrMapping/>
@@ -4705,7 +5444,7 @@
           </p:nvPr>
         </p:nvPicPr>
         <p:blipFill>
-          <a:blip r:embed="rId2"/>
+          <a:blip r:embed="rId1"/>
           <a:stretch>
             <a:fillRect/>
           </a:stretch>
@@ -4740,11 +5479,6 @@
         </p:txBody>
       </p:sp>
     </p:spTree>
-    <p:extLst>
-      <p:ext uri="{BB962C8B-B14F-4D97-AF65-F5344CB8AC3E}">
-        <p14:creationId xmlns:p14="http://schemas.microsoft.com/office/powerpoint/2010/main" val="3741599794"/>
-      </p:ext>
-    </p:extLst>
   </p:cSld>
   <p:clrMapOvr>
     <a:masterClrMapping/>
@@ -4795,7 +5529,7 @@
     </a:clrScheme>
     <a:fontScheme name="Integral">
       <a:majorFont>
-        <a:latin typeface="Tw Cen MT Condensed" panose="020B0606020104020203"/>
+        <a:latin typeface="Tw Cen MT Condensed"/>
         <a:ea typeface=""/>
         <a:cs typeface=""/>
         <a:font script="Grek" typeface="Calibri"/>
@@ -4832,7 +5566,7 @@
         <a:font script="Geor" typeface="Sylfaen"/>
       </a:majorFont>
       <a:minorFont>
-        <a:latin typeface="Tw Cen MT" panose="020B0602020104020603"/>
+        <a:latin typeface="Tw Cen MT"/>
         <a:ea typeface=""/>
         <a:cs typeface=""/>
         <a:font script="Grek" typeface="Calibri"/>
@@ -5010,11 +5744,9 @@
       </a:bgFillStyleLst>
     </a:fmtScheme>
   </a:themeElements>
-  <a:objectDefaults/>
-  <a:extraClrSchemeLst/>
   <a:extLst>
     <a:ext uri="{05A4C25C-085E-4340-85A3-A5531E510DB2}">
-      <thm15:themeFamily xmlns:thm15="http://schemas.microsoft.com/office/thememl/2012/main" name="Integral" id="{3577F8C9-A904-41D8-97D2-FD898F53F20E}" vid="{4825F1AF-8DBC-4E3D-9F3D-688338DA83FC}"/>
+      <thm15:themeFamily xmlns:thm15="http://schemas.microsoft.com/office/thememl/2012/main" name="Office Theme" id="{62F939B6-93AF-4DB8-9C6B-D6C7DFDC589F}" vid="{4A3C46E8-61CC-4603-A589-7422A47A8E4A}"/>
     </a:ext>
   </a:extLst>
 </a:theme>

</xml_diff>